<commit_message>
updated Life cycle of C doc
</commit_message>
<xml_diff>
--- a/Submissions/Robin/Understanding-Application-Security.pptx
+++ b/Submissions/Robin/Understanding-Application-Security.pptx
@@ -11,9 +11,10 @@
     <p:sldId id="259" r:id="rId5"/>
     <p:sldId id="260" r:id="rId6"/>
     <p:sldId id="261" r:id="rId7"/>
+    <p:sldId id="262" r:id="rId8"/>
   </p:sldIdLst>
   <p:notesMasterIdLst>
-    <p:notesMasterId r:id="rId8"/>
+    <p:notesMasterId r:id="rId9"/>
   </p:notesMasterIdLst>
   <p:sldSz cx="9144000" cy="5143500"/>
   <p:notesSz cx="5143500" cy="9144000"/>
@@ -989,6 +990,94 @@
             <a:fld id="{F7021451-1387-4CA6-816F-3879F97B5CBC}" type="slidenum">
               <a:rPr lang="en-US"/>
               <a:t>6</a:t>
+            </a:fld>
+            <a:endParaRPr lang="en-US"/>
+          </a:p>
+        </p:txBody>
+      </p:sp>
+    </p:spTree>
+    <p:extLst>
+      <p:ext uri="{BB962C8B-B14F-4D97-AF65-F5344CB8AC3E}">
+        <p14:creationId xmlns:p14="http://schemas.microsoft.com/office/powerpoint/2010/main" val="1024086991"/>
+      </p:ext>
+    </p:extLst>
+  </p:cSld>
+  <p:clrMapOvr>
+    <a:masterClrMapping/>
+  </p:clrMapOvr>
+</p:notes>
+</file>
+
+<file path=ppt/notesSlides/notesSlide7.xml><?xml version="1.0" encoding="utf-8"?>
+<p:notes xmlns:a="http://schemas.openxmlformats.org/drawingml/2006/main" xmlns:r="http://schemas.openxmlformats.org/officeDocument/2006/relationships" xmlns:p="http://schemas.openxmlformats.org/presentationml/2006/main">
+  <p:cSld>
+    <p:spTree>
+      <p:nvGrpSpPr>
+        <p:cNvPr id="1" name=""/>
+        <p:cNvGrpSpPr/>
+        <p:nvPr/>
+      </p:nvGrpSpPr>
+      <p:grpSpPr>
+        <a:xfrm>
+          <a:off x="0" y="0"/>
+          <a:ext cx="0" cy="0"/>
+          <a:chOff x="0" y="0"/>
+          <a:chExt cx="0" cy="0"/>
+        </a:xfrm>
+      </p:grpSpPr>
+      <p:sp>
+        <p:nvSpPr>
+          <p:cNvPr id="2" name="Slide Image Placeholder 1"/>
+          <p:cNvSpPr>
+            <a:spLocks noGrp="1" noRot="1" noChangeAspect="1"/>
+          </p:cNvSpPr>
+          <p:nvPr>
+            <p:ph type="sldImg"/>
+          </p:nvPr>
+        </p:nvSpPr>
+        <p:spPr/>
+      </p:sp>
+      <p:sp>
+        <p:nvSpPr>
+          <p:cNvPr id="3" name="Notes Placeholder 2"/>
+          <p:cNvSpPr>
+            <a:spLocks noGrp="1"/>
+          </p:cNvSpPr>
+          <p:nvPr>
+            <p:ph type="body" idx="1"/>
+          </p:nvPr>
+        </p:nvSpPr>
+        <p:spPr/>
+        <p:txBody>
+          <a:bodyPr/>
+          <a:lstStyle/>
+          <a:p>
+            <a:r>
+              <a:rPr lang="en-US" dirty="0"/>
+              <a:t/>
+            </a:r>
+            <a:endParaRPr lang="en-US" dirty="0"/>
+          </a:p>
+        </p:txBody>
+      </p:sp>
+      <p:sp>
+        <p:nvSpPr>
+          <p:cNvPr id="4" name="Slide Number Placeholder 3"/>
+          <p:cNvSpPr>
+            <a:spLocks noGrp="1"/>
+          </p:cNvSpPr>
+          <p:nvPr>
+            <p:ph type="sldNum" sz="quarter" idx="10"/>
+          </p:nvPr>
+        </p:nvSpPr>
+        <p:spPr/>
+        <p:txBody>
+          <a:bodyPr/>
+          <a:lstStyle/>
+          <a:p>
+            <a:fld id="{F7021451-1387-4CA6-816F-3879F97B5CBC}" type="slidenum">
+              <a:rPr lang="en-US"/>
+              <a:t>7</a:t>
             </a:fld>
             <a:endParaRPr lang="en-US"/>
           </a:p>
@@ -3978,6 +4067,1187 @@
       </p:grpSpPr>
       <p:sp>
         <p:nvSpPr>
+          <p:cNvPr id="2" name="Text 0"/>
+          <p:cNvSpPr/>
+          <p:nvPr/>
+        </p:nvSpPr>
+        <p:spPr>
+          <a:xfrm>
+            <a:off x="2050107" y="224061"/>
+            <a:ext cx="2056209" cy="199876"/>
+          </a:xfrm>
+          <a:prstGeom prst="rect">
+            <a:avLst/>
+          </a:prstGeom>
+          <a:noFill/>
+          <a:ln/>
+        </p:spPr>
+        <p:txBody>
+          <a:bodyPr wrap="none" lIns="0" tIns="0" rIns="0" bIns="0" rtlCol="0" anchor="t"/>
+          <a:lstStyle/>
+          <a:p>
+            <a:pPr algn="l" indent="0" marL="0">
+              <a:lnSpc>
+                <a:spcPct val="104000"/>
+              </a:lnSpc>
+              <a:buNone/>
+            </a:pPr>
+            <a:r>
+              <a:rPr lang="en-US" sz="1250" dirty="0">
+                <a:solidFill>
+                  <a:srgbClr val="FFFFFF"/>
+                </a:solidFill>
+                <a:latin typeface="Roboto Mono Medium" pitchFamily="34" charset="0"/>
+                <a:ea typeface="Roboto Mono Medium" pitchFamily="34" charset="-122"/>
+                <a:cs typeface="Roboto Mono Medium" pitchFamily="34" charset="-120"/>
+              </a:rPr>
+              <a:t>AppArmor Profile</a:t>
+            </a:r>
+            <a:endParaRPr lang="en-US" sz="1250" dirty="0"/>
+          </a:p>
+        </p:txBody>
+      </p:sp>
+      <p:sp>
+        <p:nvSpPr>
+          <p:cNvPr id="3" name="Text 1"/>
+          <p:cNvSpPr/>
+          <p:nvPr/>
+        </p:nvSpPr>
+        <p:spPr>
+          <a:xfrm>
+            <a:off x="2050107" y="489868"/>
+            <a:ext cx="5500985" cy="77539"/>
+          </a:xfrm>
+          <a:prstGeom prst="rect">
+            <a:avLst/>
+          </a:prstGeom>
+          <a:noFill/>
+          <a:ln/>
+        </p:spPr>
+        <p:txBody>
+          <a:bodyPr wrap="none" lIns="0" tIns="0" rIns="0" bIns="0" rtlCol="0" anchor="t"/>
+          <a:lstStyle/>
+          <a:p>
+            <a:pPr algn="l" indent="0" marL="0">
+              <a:lnSpc>
+                <a:spcPct val="101000"/>
+              </a:lnSpc>
+              <a:buNone/>
+            </a:pPr>
+            <a:r>
+              <a:rPr lang="en-US" sz="500" dirty="0">
+                <a:solidFill>
+                  <a:srgbClr val="E5E0DF"/>
+                </a:solidFill>
+                <a:latin typeface="Roboto" pitchFamily="34" charset="0"/>
+                <a:ea typeface="Roboto" pitchFamily="34" charset="-122"/>
+                <a:cs typeface="Roboto" pitchFamily="34" charset="-120"/>
+              </a:rPr>
+              <a:t>File name: /etc/apparmor.d/usr.sbin.apache2</a:t>
+            </a:r>
+            <a:endParaRPr lang="en-US" sz="500" dirty="0"/>
+          </a:p>
+        </p:txBody>
+      </p:sp>
+      <p:sp>
+        <p:nvSpPr>
+          <p:cNvPr id="4" name="Shape 2"/>
+          <p:cNvSpPr/>
+          <p:nvPr/>
+        </p:nvSpPr>
+        <p:spPr>
+          <a:xfrm>
+            <a:off x="2050107" y="604465"/>
+            <a:ext cx="5043785" cy="4314974"/>
+          </a:xfrm>
+          <a:prstGeom prst="roundRect">
+            <a:avLst>
+              <a:gd name="adj" fmla="val 222"/>
+            </a:avLst>
+          </a:prstGeom>
+          <a:solidFill>
+            <a:srgbClr val="2E2E2E"/>
+          </a:solidFill>
+          <a:ln/>
+        </p:spPr>
+      </p:sp>
+      <p:sp>
+        <p:nvSpPr>
+          <p:cNvPr id="5" name="Shape 3"/>
+          <p:cNvSpPr/>
+          <p:nvPr/>
+        </p:nvSpPr>
+        <p:spPr>
+          <a:xfrm>
+            <a:off x="2046982" y="604465"/>
+            <a:ext cx="5050036" cy="4314974"/>
+          </a:xfrm>
+          <a:prstGeom prst="roundRect">
+            <a:avLst>
+              <a:gd name="adj" fmla="val 222"/>
+            </a:avLst>
+          </a:prstGeom>
+          <a:solidFill>
+            <a:srgbClr val="2E2E2E"/>
+          </a:solidFill>
+          <a:ln/>
+        </p:spPr>
+      </p:sp>
+      <p:sp>
+        <p:nvSpPr>
+          <p:cNvPr id="6" name="Text 4"/>
+          <p:cNvSpPr/>
+          <p:nvPr/>
+        </p:nvSpPr>
+        <p:spPr>
+          <a:xfrm>
+            <a:off x="2126903" y="668387"/>
+            <a:ext cx="4890195" cy="4187130"/>
+          </a:xfrm>
+          <a:prstGeom prst="rect">
+            <a:avLst/>
+          </a:prstGeom>
+          <a:noFill/>
+          <a:ln/>
+        </p:spPr>
+        <p:txBody>
+          <a:bodyPr wrap="square" lIns="0" tIns="0" rIns="0" bIns="0" rtlCol="0" anchor="t">
+            <a:normAutofit/>
+          </a:bodyPr>
+          <a:lstStyle/>
+          <a:p>
+            <a:pPr algn="l" indent="0" marL="0">
+              <a:lnSpc>
+                <a:spcPct val="101000"/>
+              </a:lnSpc>
+              <a:buNone/>
+            </a:pPr>
+            <a:r>
+              <a:rPr lang="en-US" sz="500" dirty="0">
+                <a:solidFill>
+                  <a:srgbClr val="8B949E"/>
+                </a:solidFill>
+                <a:highlight>
+                  <a:srgbClr val="2E2E2E"/>
+                </a:highlight>
+                <a:latin typeface="Consolas" pitchFamily="34" charset="0"/>
+                <a:ea typeface="Consolas" pitchFamily="34" charset="-122"/>
+                <a:cs typeface="Consolas" pitchFamily="34" charset="-120"/>
+              </a:rPr>
+              <a:t># includes policy rules from another AppArmor file</a:t>
+            </a:r>
+            <a:endParaRPr lang="en-US" sz="500" dirty="0"/>
+          </a:p>
+          <a:p>
+            <a:pPr algn="l" indent="0" marL="0">
+              <a:lnSpc>
+                <a:spcPct val="101000"/>
+              </a:lnSpc>
+              <a:buNone/>
+            </a:pPr>
+            <a:r>
+              <a:rPr lang="en-US" sz="500" dirty="0">
+                <a:solidFill>
+                  <a:srgbClr val="8B949E"/>
+                </a:solidFill>
+                <a:highlight>
+                  <a:srgbClr val="2E2E2E"/>
+                </a:highlight>
+                <a:latin typeface="Consolas" pitchFamily="34" charset="0"/>
+                <a:ea typeface="Consolas" pitchFamily="34" charset="-122"/>
+                <a:cs typeface="Consolas" pitchFamily="34" charset="-120"/>
+              </a:rPr>
+              <a:t>#include &lt;tunables/global&gt;     # Loads variables and system-wide settings.</a:t>
+            </a:r>
+            <a:endParaRPr lang="en-US" sz="500" dirty="0"/>
+          </a:p>
+          <a:p>
+            <a:pPr algn="l" indent="0" marL="0">
+              <a:lnSpc>
+                <a:spcPct val="101000"/>
+              </a:lnSpc>
+              <a:buNone/>
+            </a:pPr>
+            <a:r>
+              <a:rPr lang="en-US" sz="500" dirty="0">
+                <a:solidFill>
+                  <a:srgbClr val="8B949E"/>
+                </a:solidFill>
+                <a:highlight>
+                  <a:srgbClr val="2E2E2E"/>
+                </a:highlight>
+                <a:latin typeface="Consolas" pitchFamily="34" charset="0"/>
+                <a:ea typeface="Consolas" pitchFamily="34" charset="-122"/>
+                <a:cs typeface="Consolas" pitchFamily="34" charset="-120"/>
+              </a:rPr>
+              <a:t>#include "/etc/apparmor.d/custom/myrules"</a:t>
+            </a:r>
+            <a:endParaRPr lang="en-US" sz="500" dirty="0"/>
+          </a:p>
+          <a:p>
+            <a:pPr algn="l" indent="0" marL="0">
+              <a:lnSpc>
+                <a:spcPct val="101000"/>
+              </a:lnSpc>
+              <a:buNone/>
+            </a:pPr>
+            <a:endParaRPr lang="en-US" sz="500" dirty="0"/>
+          </a:p>
+          <a:p>
+            <a:pPr algn="l" indent="0" marL="0">
+              <a:lnSpc>
+                <a:spcPct val="101000"/>
+              </a:lnSpc>
+              <a:buNone/>
+            </a:pPr>
+            <a:r>
+              <a:rPr lang="en-US" sz="500" dirty="0">
+                <a:solidFill>
+                  <a:srgbClr val="8B949E"/>
+                </a:solidFill>
+                <a:highlight>
+                  <a:srgbClr val="2E2E2E"/>
+                </a:highlight>
+                <a:latin typeface="Consolas" pitchFamily="34" charset="0"/>
+                <a:ea typeface="Consolas" pitchFamily="34" charset="-122"/>
+                <a:cs typeface="Consolas" pitchFamily="34" charset="-120"/>
+              </a:rPr>
+              <a:t>profile apache2-simple /usr/sbin/apache2 {</a:t>
+            </a:r>
+            <a:endParaRPr lang="en-US" sz="500" dirty="0"/>
+          </a:p>
+          <a:p>
+            <a:pPr algn="l" indent="0" marL="0">
+              <a:lnSpc>
+                <a:spcPct val="101000"/>
+              </a:lnSpc>
+              <a:buNone/>
+            </a:pPr>
+            <a:endParaRPr lang="en-US" sz="500" dirty="0"/>
+          </a:p>
+          <a:p>
+            <a:pPr algn="l" indent="0" marL="0">
+              <a:lnSpc>
+                <a:spcPct val="101000"/>
+              </a:lnSpc>
+              <a:buNone/>
+            </a:pPr>
+            <a:r>
+              <a:rPr lang="en-US" sz="500" dirty="0">
+                <a:solidFill>
+                  <a:srgbClr val="8B949E"/>
+                </a:solidFill>
+                <a:highlight>
+                  <a:srgbClr val="2E2E2E"/>
+                </a:highlight>
+                <a:latin typeface="Consolas" pitchFamily="34" charset="0"/>
+                <a:ea typeface="Consolas" pitchFamily="34" charset="-122"/>
+                <a:cs typeface="Consolas" pitchFamily="34" charset="-120"/>
+              </a:rPr>
+              <a:t>    # Allow reading configuration files</a:t>
+            </a:r>
+            <a:endParaRPr lang="en-US" sz="500" dirty="0"/>
+          </a:p>
+          <a:p>
+            <a:pPr algn="l" indent="0" marL="0">
+              <a:lnSpc>
+                <a:spcPct val="101000"/>
+              </a:lnSpc>
+              <a:buNone/>
+            </a:pPr>
+            <a:r>
+              <a:rPr lang="en-US" sz="500" dirty="0">
+                <a:solidFill>
+                  <a:srgbClr val="8B949E"/>
+                </a:solidFill>
+                <a:highlight>
+                  <a:srgbClr val="2E2E2E"/>
+                </a:highlight>
+                <a:latin typeface="Consolas" pitchFamily="34" charset="0"/>
+                <a:ea typeface="Consolas" pitchFamily="34" charset="-122"/>
+                <a:cs typeface="Consolas" pitchFamily="34" charset="-120"/>
+              </a:rPr>
+              <a:t>    /etc/apache2/** r,</a:t>
+            </a:r>
+            <a:endParaRPr lang="en-US" sz="500" dirty="0"/>
+          </a:p>
+          <a:p>
+            <a:pPr algn="l" indent="0" marL="0">
+              <a:lnSpc>
+                <a:spcPct val="101000"/>
+              </a:lnSpc>
+              <a:buNone/>
+            </a:pPr>
+            <a:endParaRPr lang="en-US" sz="500" dirty="0"/>
+          </a:p>
+          <a:p>
+            <a:pPr algn="l" indent="0" marL="0">
+              <a:lnSpc>
+                <a:spcPct val="101000"/>
+              </a:lnSpc>
+              <a:buNone/>
+            </a:pPr>
+            <a:r>
+              <a:rPr lang="en-US" sz="500" dirty="0">
+                <a:solidFill>
+                  <a:srgbClr val="8B949E"/>
+                </a:solidFill>
+                <a:highlight>
+                  <a:srgbClr val="2E2E2E"/>
+                </a:highlight>
+                <a:latin typeface="Consolas" pitchFamily="34" charset="0"/>
+                <a:ea typeface="Consolas" pitchFamily="34" charset="-122"/>
+                <a:cs typeface="Consolas" pitchFamily="34" charset="-120"/>
+              </a:rPr>
+              <a:t>    # Allow reading website files</a:t>
+            </a:r>
+            <a:endParaRPr lang="en-US" sz="500" dirty="0"/>
+          </a:p>
+          <a:p>
+            <a:pPr algn="l" indent="0" marL="0">
+              <a:lnSpc>
+                <a:spcPct val="101000"/>
+              </a:lnSpc>
+              <a:buNone/>
+            </a:pPr>
+            <a:r>
+              <a:rPr lang="en-US" sz="500" dirty="0">
+                <a:solidFill>
+                  <a:srgbClr val="8B949E"/>
+                </a:solidFill>
+                <a:highlight>
+                  <a:srgbClr val="2E2E2E"/>
+                </a:highlight>
+                <a:latin typeface="Consolas" pitchFamily="34" charset="0"/>
+                <a:ea typeface="Consolas" pitchFamily="34" charset="-122"/>
+                <a:cs typeface="Consolas" pitchFamily="34" charset="-120"/>
+              </a:rPr>
+              <a:t>    /var/www/html/** r,</a:t>
+            </a:r>
+            <a:endParaRPr lang="en-US" sz="500" dirty="0"/>
+          </a:p>
+          <a:p>
+            <a:pPr algn="l" indent="0" marL="0">
+              <a:lnSpc>
+                <a:spcPct val="101000"/>
+              </a:lnSpc>
+              <a:buNone/>
+            </a:pPr>
+            <a:endParaRPr lang="en-US" sz="500" dirty="0"/>
+          </a:p>
+          <a:p>
+            <a:pPr algn="l" indent="0" marL="0">
+              <a:lnSpc>
+                <a:spcPct val="101000"/>
+              </a:lnSpc>
+              <a:buNone/>
+            </a:pPr>
+            <a:r>
+              <a:rPr lang="en-US" sz="500" dirty="0">
+                <a:solidFill>
+                  <a:srgbClr val="8B949E"/>
+                </a:solidFill>
+                <a:highlight>
+                  <a:srgbClr val="2E2E2E"/>
+                </a:highlight>
+                <a:latin typeface="Consolas" pitchFamily="34" charset="0"/>
+                <a:ea typeface="Consolas" pitchFamily="34" charset="-122"/>
+                <a:cs typeface="Consolas" pitchFamily="34" charset="-120"/>
+              </a:rPr>
+              <a:t>    # Allow wesite to upload file to server</a:t>
+            </a:r>
+            <a:endParaRPr lang="en-US" sz="500" dirty="0"/>
+          </a:p>
+          <a:p>
+            <a:pPr algn="l" indent="0" marL="0">
+              <a:lnSpc>
+                <a:spcPct val="101000"/>
+              </a:lnSpc>
+              <a:buNone/>
+            </a:pPr>
+            <a:r>
+              <a:rPr lang="en-US" sz="500" dirty="0">
+                <a:solidFill>
+                  <a:srgbClr val="8B949E"/>
+                </a:solidFill>
+                <a:highlight>
+                  <a:srgbClr val="2E2E2E"/>
+                </a:highlight>
+                <a:latin typeface="Consolas" pitchFamily="34" charset="0"/>
+                <a:ea typeface="Consolas" pitchFamily="34" charset="-122"/>
+                <a:cs typeface="Consolas" pitchFamily="34" charset="-120"/>
+              </a:rPr>
+              <a:t>    /var/www/html/uploads/** rw,</a:t>
+            </a:r>
+            <a:endParaRPr lang="en-US" sz="500" dirty="0"/>
+          </a:p>
+          <a:p>
+            <a:pPr algn="l" indent="0" marL="0">
+              <a:lnSpc>
+                <a:spcPct val="101000"/>
+              </a:lnSpc>
+              <a:buNone/>
+            </a:pPr>
+            <a:endParaRPr lang="en-US" sz="500" dirty="0"/>
+          </a:p>
+          <a:p>
+            <a:pPr algn="l" indent="0" marL="0">
+              <a:lnSpc>
+                <a:spcPct val="101000"/>
+              </a:lnSpc>
+              <a:buNone/>
+            </a:pPr>
+            <a:r>
+              <a:rPr lang="en-US" sz="500" dirty="0">
+                <a:solidFill>
+                  <a:srgbClr val="8B949E"/>
+                </a:solidFill>
+                <a:highlight>
+                  <a:srgbClr val="2E2E2E"/>
+                </a:highlight>
+                <a:latin typeface="Consolas" pitchFamily="34" charset="0"/>
+                <a:ea typeface="Consolas" pitchFamily="34" charset="-122"/>
+                <a:cs typeface="Consolas" pitchFamily="34" charset="-120"/>
+              </a:rPr>
+              <a:t>    # Allow only shell scripts</a:t>
+            </a:r>
+            <a:endParaRPr lang="en-US" sz="500" dirty="0"/>
+          </a:p>
+          <a:p>
+            <a:pPr algn="l" indent="0" marL="0">
+              <a:lnSpc>
+                <a:spcPct val="101000"/>
+              </a:lnSpc>
+              <a:buNone/>
+            </a:pPr>
+            <a:r>
+              <a:rPr lang="en-US" sz="500" dirty="0">
+                <a:solidFill>
+                  <a:srgbClr val="8B949E"/>
+                </a:solidFill>
+                <a:highlight>
+                  <a:srgbClr val="2E2E2E"/>
+                </a:highlight>
+                <a:latin typeface="Consolas" pitchFamily="34" charset="0"/>
+                <a:ea typeface="Consolas" pitchFamily="34" charset="-122"/>
+                <a:cs typeface="Consolas" pitchFamily="34" charset="-120"/>
+              </a:rPr>
+              <a:t>    /home/user/scripts/*.sh ix,</a:t>
+            </a:r>
+            <a:endParaRPr lang="en-US" sz="500" dirty="0"/>
+          </a:p>
+          <a:p>
+            <a:pPr algn="l" indent="0" marL="0">
+              <a:lnSpc>
+                <a:spcPct val="101000"/>
+              </a:lnSpc>
+              <a:buNone/>
+            </a:pPr>
+            <a:endParaRPr lang="en-US" sz="500" dirty="0"/>
+          </a:p>
+          <a:p>
+            <a:pPr algn="l" indent="0" marL="0">
+              <a:lnSpc>
+                <a:spcPct val="101000"/>
+              </a:lnSpc>
+              <a:buNone/>
+            </a:pPr>
+            <a:r>
+              <a:rPr lang="en-US" sz="500" dirty="0">
+                <a:solidFill>
+                  <a:srgbClr val="8B949E"/>
+                </a:solidFill>
+                <a:highlight>
+                  <a:srgbClr val="2E2E2E"/>
+                </a:highlight>
+                <a:latin typeface="Consolas" pitchFamily="34" charset="0"/>
+                <a:ea typeface="Consolas" pitchFamily="34" charset="-122"/>
+                <a:cs typeface="Consolas" pitchFamily="34" charset="-120"/>
+              </a:rPr>
+              <a:t>    # Allow writing logs</a:t>
+            </a:r>
+            <a:endParaRPr lang="en-US" sz="500" dirty="0"/>
+          </a:p>
+          <a:p>
+            <a:pPr algn="l" indent="0" marL="0">
+              <a:lnSpc>
+                <a:spcPct val="101000"/>
+              </a:lnSpc>
+              <a:buNone/>
+            </a:pPr>
+            <a:r>
+              <a:rPr lang="en-US" sz="500" dirty="0">
+                <a:solidFill>
+                  <a:srgbClr val="8B949E"/>
+                </a:solidFill>
+                <a:highlight>
+                  <a:srgbClr val="2E2E2E"/>
+                </a:highlight>
+                <a:latin typeface="Consolas" pitchFamily="34" charset="0"/>
+                <a:ea typeface="Consolas" pitchFamily="34" charset="-122"/>
+                <a:cs typeface="Consolas" pitchFamily="34" charset="-120"/>
+              </a:rPr>
+              <a:t>    /var/log/apache2/** rw,</a:t>
+            </a:r>
+            <a:endParaRPr lang="en-US" sz="500" dirty="0"/>
+          </a:p>
+          <a:p>
+            <a:pPr algn="l" indent="0" marL="0">
+              <a:lnSpc>
+                <a:spcPct val="101000"/>
+              </a:lnSpc>
+              <a:buNone/>
+            </a:pPr>
+            <a:endParaRPr lang="en-US" sz="500" dirty="0"/>
+          </a:p>
+          <a:p>
+            <a:pPr algn="l" indent="0" marL="0">
+              <a:lnSpc>
+                <a:spcPct val="101000"/>
+              </a:lnSpc>
+              <a:buNone/>
+            </a:pPr>
+            <a:r>
+              <a:rPr lang="en-US" sz="500" dirty="0">
+                <a:solidFill>
+                  <a:srgbClr val="8B949E"/>
+                </a:solidFill>
+                <a:highlight>
+                  <a:srgbClr val="2E2E2E"/>
+                </a:highlight>
+                <a:latin typeface="Consolas" pitchFamily="34" charset="0"/>
+                <a:ea typeface="Consolas" pitchFamily="34" charset="-122"/>
+                <a:cs typeface="Consolas" pitchFamily="34" charset="-120"/>
+              </a:rPr>
+              <a:t>    # Allow access to SSL certificates</a:t>
+            </a:r>
+            <a:endParaRPr lang="en-US" sz="500" dirty="0"/>
+          </a:p>
+          <a:p>
+            <a:pPr algn="l" indent="0" marL="0">
+              <a:lnSpc>
+                <a:spcPct val="101000"/>
+              </a:lnSpc>
+              <a:buNone/>
+            </a:pPr>
+            <a:r>
+              <a:rPr lang="en-US" sz="500" dirty="0">
+                <a:solidFill>
+                  <a:srgbClr val="8B949E"/>
+                </a:solidFill>
+                <a:highlight>
+                  <a:srgbClr val="2E2E2E"/>
+                </a:highlight>
+                <a:latin typeface="Consolas" pitchFamily="34" charset="0"/>
+                <a:ea typeface="Consolas" pitchFamily="34" charset="-122"/>
+                <a:cs typeface="Consolas" pitchFamily="34" charset="-120"/>
+              </a:rPr>
+              <a:t>    /etc/ssl/** r,</a:t>
+            </a:r>
+            <a:endParaRPr lang="en-US" sz="500" dirty="0"/>
+          </a:p>
+          <a:p>
+            <a:pPr algn="l" indent="0" marL="0">
+              <a:lnSpc>
+                <a:spcPct val="101000"/>
+              </a:lnSpc>
+              <a:buNone/>
+            </a:pPr>
+            <a:endParaRPr lang="en-US" sz="500" dirty="0"/>
+          </a:p>
+          <a:p>
+            <a:pPr algn="l" indent="0" marL="0">
+              <a:lnSpc>
+                <a:spcPct val="101000"/>
+              </a:lnSpc>
+              <a:buNone/>
+            </a:pPr>
+            <a:r>
+              <a:rPr lang="en-US" sz="500" dirty="0">
+                <a:solidFill>
+                  <a:srgbClr val="8B949E"/>
+                </a:solidFill>
+                <a:highlight>
+                  <a:srgbClr val="2E2E2E"/>
+                </a:highlight>
+                <a:latin typeface="Consolas" pitchFamily="34" charset="0"/>
+                <a:ea typeface="Consolas" pitchFamily="34" charset="-122"/>
+                <a:cs typeface="Consolas" pitchFamily="34" charset="-120"/>
+              </a:rPr>
+              <a:t>    # Allow reading shared libraries</a:t>
+            </a:r>
+            <a:endParaRPr lang="en-US" sz="500" dirty="0"/>
+          </a:p>
+          <a:p>
+            <a:pPr algn="l" indent="0" marL="0">
+              <a:lnSpc>
+                <a:spcPct val="101000"/>
+              </a:lnSpc>
+              <a:buNone/>
+            </a:pPr>
+            <a:r>
+              <a:rPr lang="en-US" sz="500" dirty="0">
+                <a:solidFill>
+                  <a:srgbClr val="8B949E"/>
+                </a:solidFill>
+                <a:highlight>
+                  <a:srgbClr val="2E2E2E"/>
+                </a:highlight>
+                <a:latin typeface="Consolas" pitchFamily="34" charset="0"/>
+                <a:ea typeface="Consolas" pitchFamily="34" charset="-122"/>
+                <a:cs typeface="Consolas" pitchFamily="34" charset="-120"/>
+              </a:rPr>
+              <a:t>    /usr/lib/** r,</a:t>
+            </a:r>
+            <a:endParaRPr lang="en-US" sz="500" dirty="0"/>
+          </a:p>
+          <a:p>
+            <a:pPr algn="l" indent="0" marL="0">
+              <a:lnSpc>
+                <a:spcPct val="101000"/>
+              </a:lnSpc>
+              <a:buNone/>
+            </a:pPr>
+            <a:r>
+              <a:rPr lang="en-US" sz="500" dirty="0">
+                <a:solidFill>
+                  <a:srgbClr val="8B949E"/>
+                </a:solidFill>
+                <a:highlight>
+                  <a:srgbClr val="2E2E2E"/>
+                </a:highlight>
+                <a:latin typeface="Consolas" pitchFamily="34" charset="0"/>
+                <a:ea typeface="Consolas" pitchFamily="34" charset="-122"/>
+                <a:cs typeface="Consolas" pitchFamily="34" charset="-120"/>
+              </a:rPr>
+              <a:t>    /lib/** r,</a:t>
+            </a:r>
+            <a:endParaRPr lang="en-US" sz="500" dirty="0"/>
+          </a:p>
+          <a:p>
+            <a:pPr algn="l" indent="0" marL="0">
+              <a:lnSpc>
+                <a:spcPct val="101000"/>
+              </a:lnSpc>
+              <a:buNone/>
+            </a:pPr>
+            <a:r>
+              <a:rPr lang="en-US" sz="500" dirty="0">
+                <a:solidFill>
+                  <a:srgbClr val="8B949E"/>
+                </a:solidFill>
+                <a:highlight>
+                  <a:srgbClr val="2E2E2E"/>
+                </a:highlight>
+                <a:latin typeface="Consolas" pitchFamily="34" charset="0"/>
+                <a:ea typeface="Consolas" pitchFamily="34" charset="-122"/>
+                <a:cs typeface="Consolas" pitchFamily="34" charset="-120"/>
+              </a:rPr>
+              <a:t>    /lib64/** r,</a:t>
+            </a:r>
+            <a:endParaRPr lang="en-US" sz="500" dirty="0"/>
+          </a:p>
+          <a:p>
+            <a:pPr algn="l" indent="0" marL="0">
+              <a:lnSpc>
+                <a:spcPct val="101000"/>
+              </a:lnSpc>
+              <a:buNone/>
+            </a:pPr>
+            <a:endParaRPr lang="en-US" sz="500" dirty="0"/>
+          </a:p>
+          <a:p>
+            <a:pPr algn="l" indent="0" marL="0">
+              <a:lnSpc>
+                <a:spcPct val="101000"/>
+              </a:lnSpc>
+              <a:buNone/>
+            </a:pPr>
+            <a:r>
+              <a:rPr lang="en-US" sz="500" dirty="0">
+                <a:solidFill>
+                  <a:srgbClr val="8B949E"/>
+                </a:solidFill>
+                <a:highlight>
+                  <a:srgbClr val="2E2E2E"/>
+                </a:highlight>
+                <a:latin typeface="Consolas" pitchFamily="34" charset="0"/>
+                <a:ea typeface="Consolas" pitchFamily="34" charset="-122"/>
+                <a:cs typeface="Consolas" pitchFamily="34" charset="-120"/>
+              </a:rPr>
+              <a:t>    # Allow network access</a:t>
+            </a:r>
+            <a:endParaRPr lang="en-US" sz="500" dirty="0"/>
+          </a:p>
+          <a:p>
+            <a:pPr algn="l" indent="0" marL="0">
+              <a:lnSpc>
+                <a:spcPct val="101000"/>
+              </a:lnSpc>
+              <a:buNone/>
+            </a:pPr>
+            <a:r>
+              <a:rPr lang="en-US" sz="500" dirty="0">
+                <a:solidFill>
+                  <a:srgbClr val="8B949E"/>
+                </a:solidFill>
+                <a:highlight>
+                  <a:srgbClr val="2E2E2E"/>
+                </a:highlight>
+                <a:latin typeface="Consolas" pitchFamily="34" charset="0"/>
+                <a:ea typeface="Consolas" pitchFamily="34" charset="-122"/>
+                <a:cs typeface="Consolas" pitchFamily="34" charset="-120"/>
+              </a:rPr>
+              <a:t>    network inet stream,</a:t>
+            </a:r>
+            <a:endParaRPr lang="en-US" sz="500" dirty="0"/>
+          </a:p>
+          <a:p>
+            <a:pPr algn="l" indent="0" marL="0">
+              <a:lnSpc>
+                <a:spcPct val="101000"/>
+              </a:lnSpc>
+              <a:buNone/>
+            </a:pPr>
+            <a:r>
+              <a:rPr lang="en-US" sz="500" dirty="0">
+                <a:solidFill>
+                  <a:srgbClr val="8B949E"/>
+                </a:solidFill>
+                <a:highlight>
+                  <a:srgbClr val="2E2E2E"/>
+                </a:highlight>
+                <a:latin typeface="Consolas" pitchFamily="34" charset="0"/>
+                <a:ea typeface="Consolas" pitchFamily="34" charset="-122"/>
+                <a:cs typeface="Consolas" pitchFamily="34" charset="-120"/>
+              </a:rPr>
+              <a:t>    network inet6 dgram,</a:t>
+            </a:r>
+            <a:endParaRPr lang="en-US" sz="500" dirty="0"/>
+          </a:p>
+          <a:p>
+            <a:pPr algn="l" indent="0" marL="0">
+              <a:lnSpc>
+                <a:spcPct val="101000"/>
+              </a:lnSpc>
+              <a:buNone/>
+            </a:pPr>
+            <a:endParaRPr lang="en-US" sz="500" dirty="0"/>
+          </a:p>
+          <a:p>
+            <a:pPr algn="l" indent="0" marL="0">
+              <a:lnSpc>
+                <a:spcPct val="101000"/>
+              </a:lnSpc>
+              <a:buNone/>
+            </a:pPr>
+            <a:r>
+              <a:rPr lang="en-US" sz="500" dirty="0">
+                <a:solidFill>
+                  <a:srgbClr val="8B949E"/>
+                </a:solidFill>
+                <a:highlight>
+                  <a:srgbClr val="2E2E2E"/>
+                </a:highlight>
+                <a:latin typeface="Consolas" pitchFamily="34" charset="0"/>
+                <a:ea typeface="Consolas" pitchFamily="34" charset="-122"/>
+                <a:cs typeface="Consolas" pitchFamily="34" charset="-120"/>
+              </a:rPr>
+              <a:t>    # Allow Apache process execution</a:t>
+            </a:r>
+            <a:endParaRPr lang="en-US" sz="500" dirty="0"/>
+          </a:p>
+          <a:p>
+            <a:pPr algn="l" indent="0" marL="0">
+              <a:lnSpc>
+                <a:spcPct val="101000"/>
+              </a:lnSpc>
+              <a:buNone/>
+            </a:pPr>
+            <a:r>
+              <a:rPr lang="en-US" sz="500" dirty="0">
+                <a:solidFill>
+                  <a:srgbClr val="8B949E"/>
+                </a:solidFill>
+                <a:highlight>
+                  <a:srgbClr val="2E2E2E"/>
+                </a:highlight>
+                <a:latin typeface="Consolas" pitchFamily="34" charset="0"/>
+                <a:ea typeface="Consolas" pitchFamily="34" charset="-122"/>
+                <a:cs typeface="Consolas" pitchFamily="34" charset="-120"/>
+              </a:rPr>
+              <a:t>    /usr/sbin/apache2 mr,</a:t>
+            </a:r>
+            <a:endParaRPr lang="en-US" sz="500" dirty="0"/>
+          </a:p>
+          <a:p>
+            <a:pPr algn="l" indent="0" marL="0">
+              <a:lnSpc>
+                <a:spcPct val="101000"/>
+              </a:lnSpc>
+              <a:buNone/>
+            </a:pPr>
+            <a:endParaRPr lang="en-US" sz="500" dirty="0"/>
+          </a:p>
+          <a:p>
+            <a:pPr algn="l" indent="0" marL="0">
+              <a:lnSpc>
+                <a:spcPct val="101000"/>
+              </a:lnSpc>
+              <a:buNone/>
+            </a:pPr>
+            <a:r>
+              <a:rPr lang="en-US" sz="500" dirty="0">
+                <a:solidFill>
+                  <a:srgbClr val="8B949E"/>
+                </a:solidFill>
+                <a:highlight>
+                  <a:srgbClr val="2E2E2E"/>
+                </a:highlight>
+                <a:latin typeface="Consolas" pitchFamily="34" charset="0"/>
+                <a:ea typeface="Consolas" pitchFamily="34" charset="-122"/>
+                <a:cs typeface="Consolas" pitchFamily="34" charset="-120"/>
+              </a:rPr>
+              <a:t>    # Deny access to sensitive files</a:t>
+            </a:r>
+            <a:endParaRPr lang="en-US" sz="500" dirty="0"/>
+          </a:p>
+          <a:p>
+            <a:pPr algn="l" indent="0" marL="0">
+              <a:lnSpc>
+                <a:spcPct val="101000"/>
+              </a:lnSpc>
+              <a:buNone/>
+            </a:pPr>
+            <a:r>
+              <a:rPr lang="en-US" sz="500" dirty="0">
+                <a:solidFill>
+                  <a:srgbClr val="8B949E"/>
+                </a:solidFill>
+                <a:highlight>
+                  <a:srgbClr val="2E2E2E"/>
+                </a:highlight>
+                <a:latin typeface="Consolas" pitchFamily="34" charset="0"/>
+                <a:ea typeface="Consolas" pitchFamily="34" charset="-122"/>
+                <a:cs typeface="Consolas" pitchFamily="34" charset="-120"/>
+              </a:rPr>
+              <a:t>    deny /etc/shadow r,</a:t>
+            </a:r>
+            <a:endParaRPr lang="en-US" sz="500" dirty="0"/>
+          </a:p>
+          <a:p>
+            <a:pPr algn="l" indent="0" marL="0">
+              <a:lnSpc>
+                <a:spcPct val="101000"/>
+              </a:lnSpc>
+              <a:buNone/>
+            </a:pPr>
+            <a:r>
+              <a:rPr lang="en-US" sz="500" dirty="0">
+                <a:solidFill>
+                  <a:srgbClr val="8B949E"/>
+                </a:solidFill>
+                <a:highlight>
+                  <a:srgbClr val="2E2E2E"/>
+                </a:highlight>
+                <a:latin typeface="Consolas" pitchFamily="34" charset="0"/>
+                <a:ea typeface="Consolas" pitchFamily="34" charset="-122"/>
+                <a:cs typeface="Consolas" pitchFamily="34" charset="-120"/>
+              </a:rPr>
+              <a:t>    deny /etc/passwd w,</a:t>
+            </a:r>
+            <a:endParaRPr lang="en-US" sz="500" dirty="0"/>
+          </a:p>
+          <a:p>
+            <a:pPr algn="l" indent="0" marL="0">
+              <a:lnSpc>
+                <a:spcPct val="101000"/>
+              </a:lnSpc>
+              <a:buNone/>
+            </a:pPr>
+            <a:endParaRPr lang="en-US" sz="500" dirty="0"/>
+          </a:p>
+          <a:p>
+            <a:pPr algn="l" indent="0" marL="0">
+              <a:lnSpc>
+                <a:spcPct val="101000"/>
+              </a:lnSpc>
+              <a:buNone/>
+            </a:pPr>
+            <a:r>
+              <a:rPr lang="en-US" sz="500" dirty="0">
+                <a:solidFill>
+                  <a:srgbClr val="8B949E"/>
+                </a:solidFill>
+                <a:highlight>
+                  <a:srgbClr val="2E2E2E"/>
+                </a:highlight>
+                <a:latin typeface="Consolas" pitchFamily="34" charset="0"/>
+                <a:ea typeface="Consolas" pitchFamily="34" charset="-122"/>
+                <a:cs typeface="Consolas" pitchFamily="34" charset="-120"/>
+              </a:rPr>
+              <a:t>}</a:t>
+            </a:r>
+            <a:endParaRPr lang="en-US" sz="500" dirty="0"/>
+          </a:p>
+          <a:p>
+            <a:pPr algn="l" indent="0" marL="0">
+              <a:lnSpc>
+                <a:spcPct val="101000"/>
+              </a:lnSpc>
+              <a:buNone/>
+            </a:pPr>
+            <a:endParaRPr lang="en-US" sz="500" dirty="0"/>
+          </a:p>
+          <a:p>
+            <a:pPr algn="l" indent="0" marL="0">
+              <a:lnSpc>
+                <a:spcPct val="101000"/>
+              </a:lnSpc>
+              <a:buNone/>
+            </a:pPr>
+            <a:r>
+              <a:rPr lang="en-US" sz="500" dirty="0">
+                <a:solidFill>
+                  <a:srgbClr val="8B949E"/>
+                </a:solidFill>
+                <a:highlight>
+                  <a:srgbClr val="2E2E2E"/>
+                </a:highlight>
+                <a:latin typeface="Consolas" pitchFamily="34" charset="0"/>
+                <a:ea typeface="Consolas" pitchFamily="34" charset="-122"/>
+                <a:cs typeface="Consolas" pitchFamily="34" charset="-120"/>
+              </a:rPr>
+              <a:t>profile parent /usr/bin/parent {</a:t>
+            </a:r>
+            <a:endParaRPr lang="en-US" sz="500" dirty="0"/>
+          </a:p>
+          <a:p>
+            <a:pPr algn="l" indent="0" marL="0">
+              <a:lnSpc>
+                <a:spcPct val="101000"/>
+              </a:lnSpc>
+              <a:buNone/>
+            </a:pPr>
+            <a:endParaRPr lang="en-US" sz="500" dirty="0"/>
+          </a:p>
+          <a:p>
+            <a:pPr algn="l" indent="0" marL="0">
+              <a:lnSpc>
+                <a:spcPct val="101000"/>
+              </a:lnSpc>
+              <a:buNone/>
+            </a:pPr>
+            <a:r>
+              <a:rPr lang="en-US" sz="500" dirty="0">
+                <a:solidFill>
+                  <a:srgbClr val="8B949E"/>
+                </a:solidFill>
+                <a:highlight>
+                  <a:srgbClr val="2E2E2E"/>
+                </a:highlight>
+                <a:latin typeface="Consolas" pitchFamily="34" charset="0"/>
+                <a:ea typeface="Consolas" pitchFamily="34" charset="-122"/>
+                <a:cs typeface="Consolas" pitchFamily="34" charset="-120"/>
+              </a:rPr>
+              <a:t>    /data/** r,</a:t>
+            </a:r>
+            <a:endParaRPr lang="en-US" sz="500" dirty="0"/>
+          </a:p>
+          <a:p>
+            <a:pPr algn="l" indent="0" marL="0">
+              <a:lnSpc>
+                <a:spcPct val="101000"/>
+              </a:lnSpc>
+              <a:buNone/>
+            </a:pPr>
+            <a:endParaRPr lang="en-US" sz="500" dirty="0"/>
+          </a:p>
+          <a:p>
+            <a:pPr algn="l" indent="0" marL="0">
+              <a:lnSpc>
+                <a:spcPct val="101000"/>
+              </a:lnSpc>
+              <a:buNone/>
+            </a:pPr>
+            <a:r>
+              <a:rPr lang="en-US" sz="500" dirty="0">
+                <a:solidFill>
+                  <a:srgbClr val="8B949E"/>
+                </a:solidFill>
+                <a:highlight>
+                  <a:srgbClr val="2E2E2E"/>
+                </a:highlight>
+                <a:latin typeface="Consolas" pitchFamily="34" charset="0"/>
+                <a:ea typeface="Consolas" pitchFamily="34" charset="-122"/>
+                <a:cs typeface="Consolas" pitchFamily="34" charset="-120"/>
+              </a:rPr>
+              <a:t>    profile child {</a:t>
+            </a:r>
+            <a:endParaRPr lang="en-US" sz="500" dirty="0"/>
+          </a:p>
+          <a:p>
+            <a:pPr algn="l" indent="0" marL="0">
+              <a:lnSpc>
+                <a:spcPct val="101000"/>
+              </a:lnSpc>
+              <a:buNone/>
+            </a:pPr>
+            <a:endParaRPr lang="en-US" sz="500" dirty="0"/>
+          </a:p>
+          <a:p>
+            <a:pPr algn="l" indent="0" marL="0">
+              <a:lnSpc>
+                <a:spcPct val="101000"/>
+              </a:lnSpc>
+              <a:buNone/>
+            </a:pPr>
+            <a:r>
+              <a:rPr lang="en-US" sz="500" dirty="0">
+                <a:solidFill>
+                  <a:srgbClr val="8B949E"/>
+                </a:solidFill>
+                <a:highlight>
+                  <a:srgbClr val="2E2E2E"/>
+                </a:highlight>
+                <a:latin typeface="Consolas" pitchFamily="34" charset="0"/>
+                <a:ea typeface="Consolas" pitchFamily="34" charset="-122"/>
+                <a:cs typeface="Consolas" pitchFamily="34" charset="-120"/>
+              </a:rPr>
+              <a:t>        /tmp/** rw,</a:t>
+            </a:r>
+            <a:endParaRPr lang="en-US" sz="500" dirty="0"/>
+          </a:p>
+          <a:p>
+            <a:pPr algn="l" indent="0" marL="0">
+              <a:lnSpc>
+                <a:spcPct val="101000"/>
+              </a:lnSpc>
+              <a:buNone/>
+            </a:pPr>
+            <a:r>
+              <a:rPr lang="en-US" sz="500" dirty="0">
+                <a:solidFill>
+                  <a:srgbClr val="8B949E"/>
+                </a:solidFill>
+                <a:highlight>
+                  <a:srgbClr val="2E2E2E"/>
+                </a:highlight>
+                <a:latin typeface="Consolas" pitchFamily="34" charset="0"/>
+                <a:ea typeface="Consolas" pitchFamily="34" charset="-122"/>
+                <a:cs typeface="Consolas" pitchFamily="34" charset="-120"/>
+              </a:rPr>
+              <a:t>        /data/** r,</a:t>
+            </a:r>
+            <a:endParaRPr lang="en-US" sz="500" dirty="0"/>
+          </a:p>
+          <a:p>
+            <a:pPr algn="l" indent="0" marL="0">
+              <a:lnSpc>
+                <a:spcPct val="101000"/>
+              </a:lnSpc>
+              <a:buNone/>
+            </a:pPr>
+            <a:endParaRPr lang="en-US" sz="500" dirty="0"/>
+          </a:p>
+          <a:p>
+            <a:pPr algn="l" indent="0" marL="0">
+              <a:lnSpc>
+                <a:spcPct val="101000"/>
+              </a:lnSpc>
+              <a:buNone/>
+            </a:pPr>
+            <a:r>
+              <a:rPr lang="en-US" sz="500" dirty="0">
+                <a:solidFill>
+                  <a:srgbClr val="8B949E"/>
+                </a:solidFill>
+                <a:highlight>
+                  <a:srgbClr val="2E2E2E"/>
+                </a:highlight>
+                <a:latin typeface="Consolas" pitchFamily="34" charset="0"/>
+                <a:ea typeface="Consolas" pitchFamily="34" charset="-122"/>
+                <a:cs typeface="Consolas" pitchFamily="34" charset="-120"/>
+              </a:rPr>
+              <a:t>    }</a:t>
+            </a:r>
+            <a:endParaRPr lang="en-US" sz="500" dirty="0"/>
+          </a:p>
+          <a:p>
+            <a:pPr algn="l" indent="0" marL="0">
+              <a:lnSpc>
+                <a:spcPct val="101000"/>
+              </a:lnSpc>
+              <a:buNone/>
+            </a:pPr>
+            <a:r>
+              <a:rPr lang="en-US" sz="500" dirty="0">
+                <a:solidFill>
+                  <a:srgbClr val="8B949E"/>
+                </a:solidFill>
+                <a:highlight>
+                  <a:srgbClr val="2E2E2E"/>
+                </a:highlight>
+                <a:latin typeface="Consolas" pitchFamily="34" charset="0"/>
+                <a:ea typeface="Consolas" pitchFamily="34" charset="-122"/>
+                <a:cs typeface="Consolas" pitchFamily="34" charset="-120"/>
+              </a:rPr>
+              <a:t>}</a:t>
+            </a:r>
+            <a:endParaRPr lang="en-US" sz="500" dirty="0"/>
+          </a:p>
+          <a:p>
+            <a:pPr algn="l" indent="0" marL="0">
+              <a:lnSpc>
+                <a:spcPct val="101000"/>
+              </a:lnSpc>
+              <a:buNone/>
+            </a:pPr>
+            <a:r>
+              <a:rPr lang="en-US" sz="500" dirty="0">
+                <a:solidFill>
+                  <a:srgbClr val="8B949E"/>
+                </a:solidFill>
+                <a:highlight>
+                  <a:srgbClr val="2E2E2E"/>
+                </a:highlight>
+                <a:latin typeface="Consolas" pitchFamily="34" charset="0"/>
+                <a:ea typeface="Consolas" pitchFamily="34" charset="-122"/>
+                <a:cs typeface="Consolas" pitchFamily="34" charset="-120"/>
+              </a:rPr>
+              <a:t>    </a:t>
+            </a:r>
+            <a:endParaRPr lang="en-US" sz="500" dirty="0"/>
+          </a:p>
+        </p:txBody>
+      </p:sp>
+    </p:spTree>
+  </p:cSld>
+  <p:clrMapOvr>
+    <a:masterClrMapping/>
+  </p:clrMapOvr>
+</p:sld>
+</file>
+
+<file path=ppt/slides/slide6.xml><?xml version="1.0" encoding="utf-8"?>
+<p:sld xmlns:a="http://schemas.openxmlformats.org/drawingml/2006/main" xmlns:r="http://schemas.openxmlformats.org/officeDocument/2006/relationships" xmlns:p="http://schemas.openxmlformats.org/presentationml/2006/main">
+  <p:cSld name="Slide 6">
+    <p:spTree>
+      <p:nvGrpSpPr>
+        <p:cNvPr id="1" name=""/>
+        <p:cNvGrpSpPr/>
+        <p:nvPr/>
+      </p:nvGrpSpPr>
+      <p:grpSpPr>
+        <a:xfrm>
+          <a:off x="0" y="0"/>
+          <a:ext cx="0" cy="0"/>
+          <a:chOff x="0" y="0"/>
+          <a:chExt cx="0" cy="0"/>
+        </a:xfrm>
+      </p:grpSpPr>
+      <p:sp>
+        <p:nvSpPr>
           <p:cNvPr id="2" name="Shape 0"/>
           <p:cNvSpPr/>
           <p:nvPr/>
@@ -4832,9 +6102,9 @@
 </p:sld>
 </file>
 
-<file path=ppt/slides/slide6.xml><?xml version="1.0" encoding="utf-8"?>
+<file path=ppt/slides/slide7.xml><?xml version="1.0" encoding="utf-8"?>
 <p:sld xmlns:a="http://schemas.openxmlformats.org/drawingml/2006/main" xmlns:r="http://schemas.openxmlformats.org/officeDocument/2006/relationships" xmlns:p="http://schemas.openxmlformats.org/presentationml/2006/main">
-  <p:cSld name="Slide 6">
+  <p:cSld name="Slide 7">
     <p:spTree>
       <p:nvGrpSpPr>
         <p:cNvPr id="1" name=""/>

</xml_diff>